<commit_message>
docs(proposal): align Week 24 issue and proposal
</commit_message>
<xml_diff>
--- a/docs/proposal/Nopal-Sense_Project_Proposal.pptx
+++ b/docs/proposal/Nopal-Sense_Project_Proposal.pptx
@@ -4423,7 +4423,7 @@
             <a:br/>
             <a:r>
               <a:rPr/>
-              <a:t>Individual Track B participant</a:t>
+              <a:t>Affiliation: Universidad de Guadalajara (individual Track B participant)</a:t>
             </a:r>
           </a:p>
           <a:p>
@@ -4538,7 +4538,7 @@
             <a:br/>
             <a:r>
               <a:rPr/>
-              <a:t>Nopal-Sense aims to tape out a low-power mixed-signal soil-impedance spectroscopy ASIC for agricultural deployments. The chip generates controlled multi-frequency excitation through soil electrodes, measures the root-zone response, and exposes calibrated data through a simple SPI-controlled hub.</a:t>
+              <a:t>Design a low-power mixed-signal ASIC for repeatable soil/root-zone impedance spectroscopy using buried electrodes. The research goal is to generate dense, calibrated datasets to test whether root-zone electrical patterns can indicate abnormal biological activity, including fungal or oomycete-related signals.</a:t>
             </a:r>
           </a:p>
           <a:p>
@@ -4552,17 +4552,7 @@
             <a:br/>
             <a:r>
               <a:rPr/>
-              <a:t>The differentiating block is the soil impedance spectroscopy path: DDS/DAC excitation, electrode interface, TIA/IQ readout, filtering, and shared SAR ADC. Around it, v1 adds SPI registers, scheduler, alerts, and bridge interfaces; digital RTL is integrated under </a:t>
-            </a:r>
-            <a:r>
-              <a:rPr>
-                <a:latin typeface="Courier"/>
-              </a:rPr>
-              <a:t>v1-pico/</a:t>
-            </a:r>
-            <a:r>
-              <a:rPr/>
-              <a:t> with 185/185 Icarus assertions passing. The tapeout scope is the spectroscopy measurement platform; long-term stress/root-disease inference belongs to off-chip datasets, software, and AI models after validation.</a:t>
+              <a:t>The chip provides programmable AC excitation, electrode-interface readout, filtering, ADC access, and SPI-configurable control. It supports autonomous low-power frequency sweeps with synchronized moisture/temperature context and electrode contact/health checks. V1 is a measurement platform for calibrated soil data, not a pathogen-diagnosis chip.</a:t>
             </a:r>
           </a:p>
           <a:p>
@@ -4576,7 +4566,7 @@
             <a:br/>
             <a:r>
               <a:rPr/>
-              <a:t>Low-cost agricultural soil impedance spectroscopy for irrigation, salinity, and root-zone condition tracking, with a future data path toward software models for validated fungal/oomycete-related stress patterns.</a:t>
+              <a:t>Low-cost agricultural root-zone monitoring for irrigation, salinity, and abnormal-condition screening, with a long-term path toward validated fungal/oomycete pattern detection.</a:t>
             </a:r>
           </a:p>
           <a:p>
@@ -4590,14 +4580,14 @@
             <a:br/>
             <a:r>
               <a:rPr/>
-              <a:t>SSCS Chipathon 2026 repo and guidelines; Nopal-Sense public repo/spec/architecture; Kelleners et al., 2009; Samouelian et al., 2005.</a:t>
+              <a:t>AD5940/ADuCM355 datasheets; Bukhari et al., arXiv:2508.13379; Zhang et al., Biosensors 2025; Corona-Lopez et al., Plant Methods 2019; Settimi 2011.</a:t>
             </a:r>
           </a:p>
         </p:txBody>
       </p:sp>
       <p:pic>
         <p:nvPicPr>
-          <p:cNvPr descr="assets/nopal_sense_system.svg" id="0" name="Picture 1"/>
+          <p:cNvPr descr="assets/nopal_sense_chip_architecture.png" id="0" name="Picture 1"/>
           <p:cNvPicPr>
             <a:picLocks noGrp="1" noChangeAspect="1"/>
           </p:cNvPicPr>
@@ -4611,8 +4601,8 @@
         </p:blipFill>
         <p:spPr bwMode="auto">
           <a:xfrm>
-            <a:off x="3568700" y="1054100"/>
-            <a:ext cx="5105400" cy="2679700"/>
+            <a:off x="3568700" y="952500"/>
+            <a:ext cx="5105400" cy="2870200"/>
           </a:xfrm>
           <a:prstGeom prst="rect">
             <a:avLst/>
@@ -4781,14 +4771,14 @@
             <a:pPr lvl="0"/>
             <a:r>
               <a:rPr/>
-              <a:t>Is the v1 must-work scope realistic if limited to soil impedance spectroscopy AFE, shared SAR ADC, SPI register access, and low-power scheduling?</a:t>
+              <a:t>What is the recommended must-work scope for v1 if the full architecture is too large for the tapeout schedule?</a:t>
             </a:r>
           </a:p>
           <a:p>
             <a:pPr lvl="0"/>
             <a:r>
               <a:rPr/>
-              <a:t>Should the ADC be a custom SAR implementation in v1, or should Nopal-Sense reuse an existing open-source/reference ADC to reduce schedule risk?</a:t>
+              <a:t>Should v1 reuse an existing open-source/reference SAR ADC instead of a custom ADC design to reduce schedule risk?</a:t>
             </a:r>
           </a:p>
           <a:p>
@@ -4796,13 +4786,6 @@
             <a:r>
               <a:rPr/>
               <a:t>What electrode protection, ESD strategy, and analog pad usage are recommended for soil probes connected outside the chip package?</a:t>
-            </a:r>
-          </a:p>
-          <a:p>
-            <a:pPr lvl="0"/>
-            <a:r>
-              <a:rPr/>
-              <a:t>Are 10 kHz, 30 kHz, and 100 kHz acceptable first-tapeout frequencies for root-zone impedance, or should the top frequency be reduced for robustness?</a:t>
             </a:r>
           </a:p>
           <a:p>

</xml_diff>